<commit_message>
docs: atualizar slides de apresentacao PDF e PPTX com link do repositorio
</commit_message>
<xml_diff>
--- a/docs/presentation/VPN-IPsec-strongSwan-Matriz-Filial.pptx
+++ b/docs/presentation/VPN-IPsec-strongSwan-Matriz-Filial.pptx
@@ -20174,8 +20174,8 @@
         </p:nvSpPr>
         <p:spPr>
           <a:xfrm>
-            <a:off x="1162050" y="6295876"/>
-            <a:ext cx="3583800" cy="215400"/>
+            <a:off x="1028775" y="6310175"/>
+            <a:ext cx="3457500" cy="415500"/>
           </a:xfrm>
           <a:prstGeom prst="rect">
             <a:avLst/>
@@ -20191,6 +20191,71 @@
           </a:bodyPr>
           <a:lstStyle/>
           <a:p>
+            <a:pPr indent="0" lvl="0" marL="0" rtl="0" algn="l">
+              <a:spcBef>
+                <a:spcPts val="0"/>
+              </a:spcBef>
+              <a:spcAft>
+                <a:spcPts val="0"/>
+              </a:spcAft>
+              <a:buClr>
+                <a:schemeClr val="dk1"/>
+              </a:buClr>
+              <a:buSzPts val="1100"/>
+              <a:buFont typeface="Arial"/>
+              <a:buNone/>
+            </a:pPr>
+            <a:r>
+              <a:rPr lang="en-US" sz="900">
+                <a:solidFill>
+                  <a:srgbClr val="38BDF8"/>
+                </a:solidFill>
+                <a:latin typeface="JetBrains Mono"/>
+                <a:ea typeface="JetBrains Mono"/>
+                <a:cs typeface="JetBrains Mono"/>
+                <a:sym typeface="JetBrains Mono"/>
+              </a:rPr>
+              <a:t>github.com/RafaeldsSiqueira/strongswan-ipsec-vpn</a:t>
+            </a:r>
+            <a:endParaRPr sz="900">
+              <a:solidFill>
+                <a:srgbClr val="38BDF8"/>
+              </a:solidFill>
+              <a:latin typeface="JetBrains Mono"/>
+              <a:ea typeface="JetBrains Mono"/>
+              <a:cs typeface="JetBrains Mono"/>
+              <a:sym typeface="JetBrains Mono"/>
+            </a:endParaRPr>
+          </a:p>
+          <a:p>
+            <a:pPr indent="0" lvl="0" marL="0" rtl="0" algn="l">
+              <a:spcBef>
+                <a:spcPts val="0"/>
+              </a:spcBef>
+              <a:spcAft>
+                <a:spcPts val="0"/>
+              </a:spcAft>
+              <a:buClr>
+                <a:schemeClr val="dk1"/>
+              </a:buClr>
+              <a:buSzPts val="1100"/>
+              <a:buFont typeface="Arial"/>
+              <a:buNone/>
+            </a:pPr>
+            <a:r>
+              <a:t/>
+            </a:r>
+            <a:endParaRPr sz="900">
+              <a:solidFill>
+                <a:srgbClr val="38BDF8"/>
+              </a:solidFill>
+              <a:latin typeface="JetBrains Mono"/>
+              <a:ea typeface="JetBrains Mono"/>
+              <a:cs typeface="JetBrains Mono"/>
+              <a:sym typeface="JetBrains Mono"/>
+            </a:endParaRPr>
+          </a:p>
+          <a:p>
             <a:pPr indent="0" lvl="0" marL="0" marR="0" rtl="0" algn="l">
               <a:spcBef>
                 <a:spcPts val="0"/>
@@ -20203,7 +20268,15 @@
             <a:r>
               <a:t/>
             </a:r>
-            <a:endParaRPr/>
+            <a:endParaRPr sz="900">
+              <a:solidFill>
+                <a:srgbClr val="38BDF8"/>
+              </a:solidFill>
+              <a:latin typeface="JetBrains Mono"/>
+              <a:ea typeface="JetBrains Mono"/>
+              <a:cs typeface="JetBrains Mono"/>
+              <a:sym typeface="JetBrains Mono"/>
+            </a:endParaRPr>
           </a:p>
         </p:txBody>
       </p:sp>

</xml_diff>